<commit_message>
docs(evidence): record live RLS privacy canary
</commit_message>
<xml_diff>
--- a/CAPSTONE_OS/04_OUTPUT/slides/RAG_ENTERPRISE_FINAL_DEFENSE.pptx
+++ b/CAPSTONE_OS/04_OUTPUT/slides/RAG_ENTERPRISE_FINAL_DEFENSE.pptx
@@ -2,23 +2,23 @@
 <file path=ppt/presentation.xml><?xml version="1.0" encoding="utf-8"?>
 <p:presentation xmlns:p="http://schemas.openxmlformats.org/presentationml/2006/main">
   <p:sldMasterIdLst>
-    <p:sldMasterId xmlns:r="http://schemas.openxmlformats.org/officeDocument/2006/relationships" id="2147483648" r:id="R0483802f338a4fd9"/>
+    <p:sldMasterId xmlns:r="http://schemas.openxmlformats.org/officeDocument/2006/relationships" id="2147483648" r:id="Rad7b6a02836f497c"/>
   </p:sldMasterIdLst>
   <p:notesMasterIdLst>
-    <p:notesMasterId xmlns:r="http://schemas.openxmlformats.org/officeDocument/2006/relationships" r:id="Rb9ebc2f2e7634d97"/>
+    <p:notesMasterId xmlns:r="http://schemas.openxmlformats.org/officeDocument/2006/relationships" r:id="Re6177b04e3af4f09"/>
   </p:notesMasterIdLst>
   <p:sldIdLst>
-    <p:sldId xmlns:r="http://schemas.openxmlformats.org/officeDocument/2006/relationships" id="256" r:id="Re9f8096d90364529"/>
-    <p:sldId xmlns:r="http://schemas.openxmlformats.org/officeDocument/2006/relationships" id="257" r:id="R7db156aae044475d"/>
-    <p:sldId xmlns:r="http://schemas.openxmlformats.org/officeDocument/2006/relationships" id="258" r:id="R19bce6944cd042e4"/>
-    <p:sldId xmlns:r="http://schemas.openxmlformats.org/officeDocument/2006/relationships" id="259" r:id="Rf12298cb62fb47e2"/>
-    <p:sldId xmlns:r="http://schemas.openxmlformats.org/officeDocument/2006/relationships" id="260" r:id="Rcd19725443374c1a"/>
-    <p:sldId xmlns:r="http://schemas.openxmlformats.org/officeDocument/2006/relationships" id="261" r:id="Rfba7d358316545e6"/>
-    <p:sldId xmlns:r="http://schemas.openxmlformats.org/officeDocument/2006/relationships" id="262" r:id="R5fe0dddce9874efc"/>
-    <p:sldId xmlns:r="http://schemas.openxmlformats.org/officeDocument/2006/relationships" id="263" r:id="R0914c2a918a540b9"/>
-    <p:sldId xmlns:r="http://schemas.openxmlformats.org/officeDocument/2006/relationships" id="264" r:id="Rf9d40d2cb7c84046"/>
-    <p:sldId xmlns:r="http://schemas.openxmlformats.org/officeDocument/2006/relationships" id="265" r:id="R8283f5638b2242ce"/>
-    <p:sldId xmlns:r="http://schemas.openxmlformats.org/officeDocument/2006/relationships" id="266" r:id="R6c8e4b7b9bc94e82"/>
+    <p:sldId xmlns:r="http://schemas.openxmlformats.org/officeDocument/2006/relationships" id="256" r:id="Rd630f033de544a91"/>
+    <p:sldId xmlns:r="http://schemas.openxmlformats.org/officeDocument/2006/relationships" id="257" r:id="R4036858e199241f5"/>
+    <p:sldId xmlns:r="http://schemas.openxmlformats.org/officeDocument/2006/relationships" id="258" r:id="R5aa0edca08184791"/>
+    <p:sldId xmlns:r="http://schemas.openxmlformats.org/officeDocument/2006/relationships" id="259" r:id="R77294cafc41b4a85"/>
+    <p:sldId xmlns:r="http://schemas.openxmlformats.org/officeDocument/2006/relationships" id="260" r:id="Rf7df869c41064d6b"/>
+    <p:sldId xmlns:r="http://schemas.openxmlformats.org/officeDocument/2006/relationships" id="261" r:id="R5fb44a8690d347ae"/>
+    <p:sldId xmlns:r="http://schemas.openxmlformats.org/officeDocument/2006/relationships" id="262" r:id="R6f220ff0413542f3"/>
+    <p:sldId xmlns:r="http://schemas.openxmlformats.org/officeDocument/2006/relationships" id="263" r:id="R50e711279a184232"/>
+    <p:sldId xmlns:r="http://schemas.openxmlformats.org/officeDocument/2006/relationships" id="264" r:id="Rf82e79f476fc4cd5"/>
+    <p:sldId xmlns:r="http://schemas.openxmlformats.org/officeDocument/2006/relationships" id="265" r:id="R6a4ce7f8ca4c4133"/>
+    <p:sldId xmlns:r="http://schemas.openxmlformats.org/officeDocument/2006/relationships" id="266" r:id="Ra293279363334ae3"/>
   </p:sldIdLst>
   <p:sldSz cx="12192000" cy="6858000"/>
   <p:notesSz cx="6858000" cy="9144000"/>
@@ -1357,7 +1357,7 @@
           <a:lstStyle xmlns:a="http://schemas.openxmlformats.org/drawingml/2006/main"/>
           <a:p xmlns:a="http://schemas.openxmlformats.org/drawingml/2006/main">
             <a:r>
-              <a:t>Nêu defense-in-depth: route kiểm tra role để UX rõ ràng, nhưng ranh giới bảo mật thật nằm ở RLS của database. Không claim live two-user canary vì chưa chạy.</a:t>
+              <a:t>Nêu defense-in-depth: route kiểm tra role để UX rõ ràng, nhưng ranh giới bảo mật thật nằm ở RLS. Live canary hai phòng ban đã pass trên public preview; đây vẫn chưa phải production security audit.</a:t>
             </a:r>
           </a:p>
           <a:p xmlns:a="http://schemas.openxmlformats.org/drawingml/2006/main">
@@ -1377,12 +1377,12 @@
           </a:p>
           <a:p xmlns:a="http://schemas.openxmlformats.org/drawingml/2006/main">
             <a:r>
-              <a:t>- webapp/supabase_backend.py</a:t>
-            </a:r>
-          </a:p>
-          <a:p xmlns:a="http://schemas.openxmlformats.org/drawingml/2006/main">
-            <a:r>
               <a:t>- artifacts/web/supabase_schema_smoke.json</a:t>
+            </a:r>
+          </a:p>
+          <a:p xmlns:a="http://schemas.openxmlformats.org/drawingml/2006/main">
+            <a:r>
+              <a:t>- artifacts/web/supabase_live_canary.json</a:t>
             </a:r>
           </a:p>
           <a:p xmlns:a="http://schemas.openxmlformats.org/drawingml/2006/main">
@@ -1560,7 +1560,7 @@
   </p:cSld>
   <p:clrMap bg1="lt1" tx1="dk1" bg2="lt2" tx2="dk2" accent1="accent1" accent2="accent2" accent3="accent3" accent4="accent4" accent5="accent5" accent6="accent6" hlink="hlink" folHlink="folHlink"/>
   <p:sldLayoutIdLst>
-    <p:sldLayoutId xmlns:r="http://schemas.openxmlformats.org/officeDocument/2006/relationships" id="2147483649" r:id="R9a4933a8c68b458b"/>
+    <p:sldLayoutId xmlns:r="http://schemas.openxmlformats.org/officeDocument/2006/relationships" id="2147483649" r:id="R40cbcf2e68a74e9b"/>
   </p:sldLayoutIdLst>
   <p:txStyles>
     <p:titleStyle>
@@ -2575,7 +2575,7 @@
                   <a:srgbClr val="0F766E"/>
                 </a:solidFill>
               </a:rPr>
-              <a:t>MRR 0.945 • 61 tests pass • Public demo</a:t>
+              <a:t>MRR 0.945 • 63 tests pass • Public demo</a:t>
             </a:r>
           </a:p>
         </p:txBody>
@@ -3738,7 +3738,7 @@
                   <a:srgbClr val="0F172A"/>
                 </a:solidFill>
               </a:rPr>
-              <a:t>Supabase live two-user canary</a:t>
+              <a:t>Production security audit</a:t>
             </a:r>
           </a:p>
           <a:p xmlns:a="http://schemas.openxmlformats.org/drawingml/2006/main">
@@ -7404,7 +7404,7 @@
         </p:xfrm>
         <a:graphic xmlns:a="http://schemas.openxmlformats.org/drawingml/2006/main">
           <a:graphicData uri="http://schemas.openxmlformats.org/drawingml/2006/chart">
-            <c:chart xmlns:r="http://schemas.openxmlformats.org/officeDocument/2006/relationships" xmlns:c="http://schemas.openxmlformats.org/drawingml/2006/chart" r:id="R80feefa480cb4a59"/>
+            <c:chart xmlns:r="http://schemas.openxmlformats.org/officeDocument/2006/relationships" xmlns:c="http://schemas.openxmlformats.org/drawingml/2006/chart" r:id="R309a234613374187"/>
           </a:graphicData>
         </a:graphic>
       </p:graphicFrame>
@@ -9076,7 +9076,7 @@
                   <a:srgbClr val="0F172A"/>
                 </a:solidFill>
               </a:rPr>
-              <a:t>• Manager bị chặn truy cập chéo phòng ban</a:t>
+              <a:t>• Live canary HR ↔ Finance: không list/retrieve chéo phòng</a:t>
             </a:r>
           </a:p>
           <a:p xmlns:a="http://schemas.openxmlformats.org/drawingml/2006/main">

</xml_diff>

<commit_message>
docs(release): verify permanent admin and close handoff
</commit_message>
<xml_diff>
--- a/CAPSTONE_OS/04_OUTPUT/slides/RAG_ENTERPRISE_FINAL_DEFENSE.pptx
+++ b/CAPSTONE_OS/04_OUTPUT/slides/RAG_ENTERPRISE_FINAL_DEFENSE.pptx
@@ -2,23 +2,23 @@
 <file path=ppt/presentation.xml><?xml version="1.0" encoding="utf-8"?>
 <p:presentation xmlns:p="http://schemas.openxmlformats.org/presentationml/2006/main">
   <p:sldMasterIdLst>
-    <p:sldMasterId xmlns:r="http://schemas.openxmlformats.org/officeDocument/2006/relationships" id="2147483648" r:id="Rad7b6a02836f497c"/>
+    <p:sldMasterId xmlns:r="http://schemas.openxmlformats.org/officeDocument/2006/relationships" id="2147483648" r:id="R00cfa28a75a3465b"/>
   </p:sldMasterIdLst>
   <p:notesMasterIdLst>
-    <p:notesMasterId xmlns:r="http://schemas.openxmlformats.org/officeDocument/2006/relationships" r:id="Re6177b04e3af4f09"/>
+    <p:notesMasterId xmlns:r="http://schemas.openxmlformats.org/officeDocument/2006/relationships" r:id="R6bf699d432804704"/>
   </p:notesMasterIdLst>
   <p:sldIdLst>
-    <p:sldId xmlns:r="http://schemas.openxmlformats.org/officeDocument/2006/relationships" id="256" r:id="Rd630f033de544a91"/>
-    <p:sldId xmlns:r="http://schemas.openxmlformats.org/officeDocument/2006/relationships" id="257" r:id="R4036858e199241f5"/>
-    <p:sldId xmlns:r="http://schemas.openxmlformats.org/officeDocument/2006/relationships" id="258" r:id="R5aa0edca08184791"/>
-    <p:sldId xmlns:r="http://schemas.openxmlformats.org/officeDocument/2006/relationships" id="259" r:id="R77294cafc41b4a85"/>
-    <p:sldId xmlns:r="http://schemas.openxmlformats.org/officeDocument/2006/relationships" id="260" r:id="Rf7df869c41064d6b"/>
-    <p:sldId xmlns:r="http://schemas.openxmlformats.org/officeDocument/2006/relationships" id="261" r:id="R5fb44a8690d347ae"/>
-    <p:sldId xmlns:r="http://schemas.openxmlformats.org/officeDocument/2006/relationships" id="262" r:id="R6f220ff0413542f3"/>
-    <p:sldId xmlns:r="http://schemas.openxmlformats.org/officeDocument/2006/relationships" id="263" r:id="R50e711279a184232"/>
-    <p:sldId xmlns:r="http://schemas.openxmlformats.org/officeDocument/2006/relationships" id="264" r:id="Rf82e79f476fc4cd5"/>
-    <p:sldId xmlns:r="http://schemas.openxmlformats.org/officeDocument/2006/relationships" id="265" r:id="R6a4ce7f8ca4c4133"/>
-    <p:sldId xmlns:r="http://schemas.openxmlformats.org/officeDocument/2006/relationships" id="266" r:id="Ra293279363334ae3"/>
+    <p:sldId xmlns:r="http://schemas.openxmlformats.org/officeDocument/2006/relationships" id="256" r:id="Rf04d53a0d4da47ff"/>
+    <p:sldId xmlns:r="http://schemas.openxmlformats.org/officeDocument/2006/relationships" id="257" r:id="Rfe736f779566464d"/>
+    <p:sldId xmlns:r="http://schemas.openxmlformats.org/officeDocument/2006/relationships" id="258" r:id="R7e7108c0cb6749c7"/>
+    <p:sldId xmlns:r="http://schemas.openxmlformats.org/officeDocument/2006/relationships" id="259" r:id="R0bb64a3fda2c4dcd"/>
+    <p:sldId xmlns:r="http://schemas.openxmlformats.org/officeDocument/2006/relationships" id="260" r:id="R7ae588154f5540bc"/>
+    <p:sldId xmlns:r="http://schemas.openxmlformats.org/officeDocument/2006/relationships" id="261" r:id="Redd799c3b02e46e9"/>
+    <p:sldId xmlns:r="http://schemas.openxmlformats.org/officeDocument/2006/relationships" id="262" r:id="R22cf7ae163cb4126"/>
+    <p:sldId xmlns:r="http://schemas.openxmlformats.org/officeDocument/2006/relationships" id="263" r:id="R3c466f0a143540e1"/>
+    <p:sldId xmlns:r="http://schemas.openxmlformats.org/officeDocument/2006/relationships" id="264" r:id="R72ea2c12346048bd"/>
+    <p:sldId xmlns:r="http://schemas.openxmlformats.org/officeDocument/2006/relationships" id="265" r:id="R00d8652b0ebe47dd"/>
+    <p:sldId xmlns:r="http://schemas.openxmlformats.org/officeDocument/2006/relationships" id="266" r:id="R91c8ba24d9f141d0"/>
   </p:sldIdLst>
   <p:sldSz cx="12192000" cy="6858000"/>
   <p:notesSz cx="6858000" cy="9144000"/>
@@ -1560,7 +1560,7 @@
   </p:cSld>
   <p:clrMap bg1="lt1" tx1="dk1" bg2="lt2" tx2="dk2" accent1="accent1" accent2="accent2" accent3="accent3" accent4="accent4" accent5="accent5" accent6="accent6" hlink="hlink" folHlink="folHlink"/>
   <p:sldLayoutIdLst>
-    <p:sldLayoutId xmlns:r="http://schemas.openxmlformats.org/officeDocument/2006/relationships" id="2147483649" r:id="R40cbcf2e68a74e9b"/>
+    <p:sldLayoutId xmlns:r="http://schemas.openxmlformats.org/officeDocument/2006/relationships" id="2147483649" r:id="Rded563a3b1154c81"/>
   </p:sldLayoutIdLst>
   <p:txStyles>
     <p:titleStyle>
@@ -3529,7 +3529,7 @@
                   <a:srgbClr val="0F172A"/>
                 </a:solidFill>
               </a:rPr>
-              <a:t>• Admin bootstrap vẫn cần thao tác người dùng có kiểm soát</a:t>
+              <a:t>• Permanent admin đã bootstrap; public login và quyền quản trị pass</a:t>
             </a:r>
           </a:p>
           <a:p xmlns:a="http://schemas.openxmlformats.org/drawingml/2006/main">
@@ -7404,7 +7404,7 @@
         </p:xfrm>
         <a:graphic xmlns:a="http://schemas.openxmlformats.org/drawingml/2006/main">
           <a:graphicData uri="http://schemas.openxmlformats.org/drawingml/2006/chart">
-            <c:chart xmlns:r="http://schemas.openxmlformats.org/officeDocument/2006/relationships" xmlns:c="http://schemas.openxmlformats.org/drawingml/2006/chart" r:id="R309a234613374187"/>
+            <c:chart xmlns:r="http://schemas.openxmlformats.org/officeDocument/2006/relationships" xmlns:c="http://schemas.openxmlformats.org/drawingml/2006/chart" r:id="R2b4fc2327b55425e"/>
           </a:graphicData>
         </a:graphic>
       </p:graphicFrame>

</xml_diff>